<commit_message>
final project 1 commit
</commit_message>
<xml_diff>
--- a/Project1/Reports/Nagel_Project1_Presentation.pptx
+++ b/Project1/Reports/Nagel_Project1_Presentation.pptx
@@ -124,7 +124,7 @@
 <file path=ppt/revisionInfo.xml><?xml version="1.0" encoding="utf-8"?>
 <p1510:revInfo xmlns:a="http://schemas.openxmlformats.org/drawingml/2006/main" xmlns:r="http://schemas.openxmlformats.org/officeDocument/2006/relationships" xmlns:p1510="http://schemas.microsoft.com/office/powerpoint/2015/10/main">
   <p1510:revLst>
-    <p1510:client id="{B923A2C6-2521-4BE7-BAFD-35F29B136EE3}" v="163" dt="2026-03-02T16:05:00.921"/>
+    <p1510:client id="{B923A2C6-2521-4BE7-BAFD-35F29B136EE3}" v="174" dt="2026-03-02T18:48:41.574"/>
   </p1510:revLst>
 </p1510:revInfo>
 </file>
@@ -134,7 +134,7 @@
   <pc:docChgLst>
     <pc:chgData name="Joe Nagel" userId="7dedc618e2aa6ce6" providerId="LiveId" clId="{9ECCC3C5-1F9C-40AE-8D6E-A626AAE8C160}"/>
     <pc:docChg chg="undo redo custSel addSld delSld modSld">
-      <pc:chgData name="Joe Nagel" userId="7dedc618e2aa6ce6" providerId="LiveId" clId="{9ECCC3C5-1F9C-40AE-8D6E-A626AAE8C160}" dt="2026-03-02T16:09:05.852" v="3202" actId="20577"/>
+      <pc:chgData name="Joe Nagel" userId="7dedc618e2aa6ce6" providerId="LiveId" clId="{9ECCC3C5-1F9C-40AE-8D6E-A626AAE8C160}" dt="2026-03-02T18:48:41.574" v="3665" actId="20577"/>
       <pc:docMkLst>
         <pc:docMk/>
       </pc:docMkLst>
@@ -162,13 +162,13 @@
         </pc:spChg>
       </pc:sldChg>
       <pc:sldChg chg="modSp mod">
-        <pc:chgData name="Joe Nagel" userId="7dedc618e2aa6ce6" providerId="LiveId" clId="{9ECCC3C5-1F9C-40AE-8D6E-A626AAE8C160}" dt="2026-03-02T16:09:05.852" v="3202" actId="20577"/>
+        <pc:chgData name="Joe Nagel" userId="7dedc618e2aa6ce6" providerId="LiveId" clId="{9ECCC3C5-1F9C-40AE-8D6E-A626AAE8C160}" dt="2026-03-02T16:49:10.007" v="3302" actId="20577"/>
         <pc:sldMkLst>
           <pc:docMk/>
           <pc:sldMk cId="4230202104" sldId="257"/>
         </pc:sldMkLst>
         <pc:spChg chg="mod">
-          <ac:chgData name="Joe Nagel" userId="7dedc618e2aa6ce6" providerId="LiveId" clId="{9ECCC3C5-1F9C-40AE-8D6E-A626AAE8C160}" dt="2026-03-02T16:09:05.852" v="3202" actId="20577"/>
+          <ac:chgData name="Joe Nagel" userId="7dedc618e2aa6ce6" providerId="LiveId" clId="{9ECCC3C5-1F9C-40AE-8D6E-A626AAE8C160}" dt="2026-03-02T16:49:10.007" v="3302" actId="20577"/>
           <ac:spMkLst>
             <pc:docMk/>
             <pc:sldMk cId="4230202104" sldId="257"/>
@@ -177,17 +177,25 @@
         </pc:spChg>
       </pc:sldChg>
       <pc:sldChg chg="addSp delSp modSp mod">
-        <pc:chgData name="Joe Nagel" userId="7dedc618e2aa6ce6" providerId="LiveId" clId="{9ECCC3C5-1F9C-40AE-8D6E-A626AAE8C160}" dt="2026-03-02T07:05:01.376" v="1818" actId="20577"/>
+        <pc:chgData name="Joe Nagel" userId="7dedc618e2aa6ce6" providerId="LiveId" clId="{9ECCC3C5-1F9C-40AE-8D6E-A626AAE8C160}" dt="2026-03-02T16:40:56.807" v="3286" actId="14100"/>
         <pc:sldMkLst>
           <pc:docMk/>
           <pc:sldMk cId="25113018" sldId="258"/>
         </pc:sldMkLst>
         <pc:spChg chg="mod">
-          <ac:chgData name="Joe Nagel" userId="7dedc618e2aa6ce6" providerId="LiveId" clId="{9ECCC3C5-1F9C-40AE-8D6E-A626AAE8C160}" dt="2026-03-02T07:05:01.376" v="1818" actId="20577"/>
+          <ac:chgData name="Joe Nagel" userId="7dedc618e2aa6ce6" providerId="LiveId" clId="{9ECCC3C5-1F9C-40AE-8D6E-A626AAE8C160}" dt="2026-03-02T16:40:06.894" v="3280" actId="20577"/>
           <ac:spMkLst>
             <pc:docMk/>
             <pc:sldMk cId="25113018" sldId="258"/>
             <ac:spMk id="3" creationId="{A4CEC750-A8D1-9F91-D7A6-9E0E88E3D906}"/>
+          </ac:spMkLst>
+        </pc:spChg>
+        <pc:spChg chg="add mod">
+          <ac:chgData name="Joe Nagel" userId="7dedc618e2aa6ce6" providerId="LiveId" clId="{9ECCC3C5-1F9C-40AE-8D6E-A626AAE8C160}" dt="2026-03-02T16:40:56.807" v="3286" actId="14100"/>
+          <ac:spMkLst>
+            <pc:docMk/>
+            <pc:sldMk cId="25113018" sldId="258"/>
+            <ac:spMk id="5" creationId="{6B6D4E1D-36AD-DBA0-97B4-432C7C311BD7}"/>
           </ac:spMkLst>
         </pc:spChg>
         <pc:picChg chg="add mod">
@@ -208,7 +216,7 @@
         </pc:picChg>
       </pc:sldChg>
       <pc:sldChg chg="addSp delSp modSp mod">
-        <pc:chgData name="Joe Nagel" userId="7dedc618e2aa6ce6" providerId="LiveId" clId="{9ECCC3C5-1F9C-40AE-8D6E-A626AAE8C160}" dt="2026-03-02T07:04:45.736" v="1813" actId="478"/>
+        <pc:chgData name="Joe Nagel" userId="7dedc618e2aa6ce6" providerId="LiveId" clId="{9ECCC3C5-1F9C-40AE-8D6E-A626AAE8C160}" dt="2026-03-02T18:39:58.136" v="3629" actId="20577"/>
         <pc:sldMkLst>
           <pc:docMk/>
           <pc:sldMk cId="3889094601" sldId="259"/>
@@ -222,7 +230,7 @@
           </ac:spMkLst>
         </pc:spChg>
         <pc:spChg chg="add mod">
-          <ac:chgData name="Joe Nagel" userId="7dedc618e2aa6ce6" providerId="LiveId" clId="{9ECCC3C5-1F9C-40AE-8D6E-A626AAE8C160}" dt="2026-03-02T06:42:56.857" v="1461"/>
+          <ac:chgData name="Joe Nagel" userId="7dedc618e2aa6ce6" providerId="LiveId" clId="{9ECCC3C5-1F9C-40AE-8D6E-A626AAE8C160}" dt="2026-03-02T18:25:01.690" v="3574" actId="20577"/>
           <ac:spMkLst>
             <pc:docMk/>
             <pc:sldMk cId="3889094601" sldId="259"/>
@@ -230,7 +238,7 @@
           </ac:spMkLst>
         </pc:spChg>
         <pc:spChg chg="add mod">
-          <ac:chgData name="Joe Nagel" userId="7dedc618e2aa6ce6" providerId="LiveId" clId="{9ECCC3C5-1F9C-40AE-8D6E-A626AAE8C160}" dt="2026-03-02T07:04:42.027" v="1812" actId="1076"/>
+          <ac:chgData name="Joe Nagel" userId="7dedc618e2aa6ce6" providerId="LiveId" clId="{9ECCC3C5-1F9C-40AE-8D6E-A626AAE8C160}" dt="2026-03-02T18:39:58.136" v="3629" actId="20577"/>
           <ac:spMkLst>
             <pc:docMk/>
             <pc:sldMk cId="3889094601" sldId="259"/>
@@ -247,7 +255,7 @@
         </pc:spChg>
       </pc:sldChg>
       <pc:sldChg chg="addSp delSp modSp mod">
-        <pc:chgData name="Joe Nagel" userId="7dedc618e2aa6ce6" providerId="LiveId" clId="{9ECCC3C5-1F9C-40AE-8D6E-A626AAE8C160}" dt="2026-03-02T15:54:11.232" v="2788" actId="1038"/>
+        <pc:chgData name="Joe Nagel" userId="7dedc618e2aa6ce6" providerId="LiveId" clId="{9ECCC3C5-1F9C-40AE-8D6E-A626AAE8C160}" dt="2026-03-02T17:58:36.066" v="3307" actId="1076"/>
         <pc:sldMkLst>
           <pc:docMk/>
           <pc:sldMk cId="2686114532" sldId="260"/>
@@ -269,7 +277,7 @@
           </ac:spMkLst>
         </pc:spChg>
         <pc:spChg chg="add mod">
-          <ac:chgData name="Joe Nagel" userId="7dedc618e2aa6ce6" providerId="LiveId" clId="{9ECCC3C5-1F9C-40AE-8D6E-A626AAE8C160}" dt="2026-03-02T15:53:38.705" v="2780" actId="20577"/>
+          <ac:chgData name="Joe Nagel" userId="7dedc618e2aa6ce6" providerId="LiveId" clId="{9ECCC3C5-1F9C-40AE-8D6E-A626AAE8C160}" dt="2026-03-02T17:56:40.598" v="3304" actId="20577"/>
           <ac:spMkLst>
             <pc:docMk/>
             <pc:sldMk cId="2686114532" sldId="260"/>
@@ -277,7 +285,7 @@
           </ac:spMkLst>
         </pc:spChg>
         <pc:picChg chg="add mod">
-          <ac:chgData name="Joe Nagel" userId="7dedc618e2aa6ce6" providerId="LiveId" clId="{9ECCC3C5-1F9C-40AE-8D6E-A626AAE8C160}" dt="2026-03-02T06:49:08.897" v="1497" actId="1076"/>
+          <ac:chgData name="Joe Nagel" userId="7dedc618e2aa6ce6" providerId="LiveId" clId="{9ECCC3C5-1F9C-40AE-8D6E-A626AAE8C160}" dt="2026-03-02T17:58:36.066" v="3307" actId="1076"/>
           <ac:picMkLst>
             <pc:docMk/>
             <pc:sldMk cId="2686114532" sldId="260"/>
@@ -293,7 +301,7 @@
           </ac:picMkLst>
         </pc:picChg>
         <pc:picChg chg="add mod">
-          <ac:chgData name="Joe Nagel" userId="7dedc618e2aa6ce6" providerId="LiveId" clId="{9ECCC3C5-1F9C-40AE-8D6E-A626AAE8C160}" dt="2026-03-02T15:54:11.232" v="2788" actId="1038"/>
+          <ac:chgData name="Joe Nagel" userId="7dedc618e2aa6ce6" providerId="LiveId" clId="{9ECCC3C5-1F9C-40AE-8D6E-A626AAE8C160}" dt="2026-03-02T17:58:32.144" v="3306" actId="14100"/>
           <ac:picMkLst>
             <pc:docMk/>
             <pc:sldMk cId="2686114532" sldId="260"/>
@@ -349,13 +357,13 @@
         </pc:picChg>
       </pc:sldChg>
       <pc:sldChg chg="modSp mod">
-        <pc:chgData name="Joe Nagel" userId="7dedc618e2aa6ce6" providerId="LiveId" clId="{9ECCC3C5-1F9C-40AE-8D6E-A626AAE8C160}" dt="2026-03-02T16:05:04.336" v="3160" actId="20577"/>
+        <pc:chgData name="Joe Nagel" userId="7dedc618e2aa6ce6" providerId="LiveId" clId="{9ECCC3C5-1F9C-40AE-8D6E-A626AAE8C160}" dt="2026-03-02T18:48:41.574" v="3665" actId="20577"/>
         <pc:sldMkLst>
           <pc:docMk/>
           <pc:sldMk cId="3047217674" sldId="262"/>
         </pc:sldMkLst>
         <pc:spChg chg="mod">
-          <ac:chgData name="Joe Nagel" userId="7dedc618e2aa6ce6" providerId="LiveId" clId="{9ECCC3C5-1F9C-40AE-8D6E-A626AAE8C160}" dt="2026-03-02T16:05:04.336" v="3160" actId="20577"/>
+          <ac:chgData name="Joe Nagel" userId="7dedc618e2aa6ce6" providerId="LiveId" clId="{9ECCC3C5-1F9C-40AE-8D6E-A626AAE8C160}" dt="2026-03-02T18:48:41.574" v="3665" actId="20577"/>
           <ac:spMkLst>
             <pc:docMk/>
             <pc:sldMk cId="3047217674" sldId="262"/>
@@ -457,7 +465,7 @@
           <a:p>
             <a:fld id="{EE737CE6-89CC-4B26-BF23-83552D005AE3}" type="datetimeFigureOut">
               <a:rPr lang="en-US" smtClean="0"/>
-              <a:t>3/1/2026</a:t>
+              <a:t>3/2/2026</a:t>
             </a:fld>
             <a:endParaRPr lang="en-US"/>
           </a:p>
@@ -1039,7 +1047,7 @@
           <a:p>
             <a:fld id="{BA94432C-A2F8-4335-967E-A9297080D7C3}" type="datetimeFigureOut">
               <a:rPr lang="en-US" smtClean="0"/>
-              <a:t>3/1/2026</a:t>
+              <a:t>3/2/2026</a:t>
             </a:fld>
             <a:endParaRPr lang="en-US"/>
           </a:p>
@@ -1237,7 +1245,7 @@
           <a:p>
             <a:fld id="{BA94432C-A2F8-4335-967E-A9297080D7C3}" type="datetimeFigureOut">
               <a:rPr lang="en-US" smtClean="0"/>
-              <a:t>3/1/2026</a:t>
+              <a:t>3/2/2026</a:t>
             </a:fld>
             <a:endParaRPr lang="en-US"/>
           </a:p>
@@ -1445,7 +1453,7 @@
           <a:p>
             <a:fld id="{BA94432C-A2F8-4335-967E-A9297080D7C3}" type="datetimeFigureOut">
               <a:rPr lang="en-US" smtClean="0"/>
-              <a:t>3/1/2026</a:t>
+              <a:t>3/2/2026</a:t>
             </a:fld>
             <a:endParaRPr lang="en-US"/>
           </a:p>
@@ -1643,7 +1651,7 @@
           <a:p>
             <a:fld id="{BA94432C-A2F8-4335-967E-A9297080D7C3}" type="datetimeFigureOut">
               <a:rPr lang="en-US" smtClean="0"/>
-              <a:t>3/1/2026</a:t>
+              <a:t>3/2/2026</a:t>
             </a:fld>
             <a:endParaRPr lang="en-US"/>
           </a:p>
@@ -1918,7 +1926,7 @@
           <a:p>
             <a:fld id="{BA94432C-A2F8-4335-967E-A9297080D7C3}" type="datetimeFigureOut">
               <a:rPr lang="en-US" smtClean="0"/>
-              <a:t>3/1/2026</a:t>
+              <a:t>3/2/2026</a:t>
             </a:fld>
             <a:endParaRPr lang="en-US"/>
           </a:p>
@@ -2183,7 +2191,7 @@
           <a:p>
             <a:fld id="{BA94432C-A2F8-4335-967E-A9297080D7C3}" type="datetimeFigureOut">
               <a:rPr lang="en-US" smtClean="0"/>
-              <a:t>3/1/2026</a:t>
+              <a:t>3/2/2026</a:t>
             </a:fld>
             <a:endParaRPr lang="en-US"/>
           </a:p>
@@ -2595,7 +2603,7 @@
           <a:p>
             <a:fld id="{BA94432C-A2F8-4335-967E-A9297080D7C3}" type="datetimeFigureOut">
               <a:rPr lang="en-US" smtClean="0"/>
-              <a:t>3/1/2026</a:t>
+              <a:t>3/2/2026</a:t>
             </a:fld>
             <a:endParaRPr lang="en-US"/>
           </a:p>
@@ -2736,7 +2744,7 @@
           <a:p>
             <a:fld id="{BA94432C-A2F8-4335-967E-A9297080D7C3}" type="datetimeFigureOut">
               <a:rPr lang="en-US" smtClean="0"/>
-              <a:t>3/1/2026</a:t>
+              <a:t>3/2/2026</a:t>
             </a:fld>
             <a:endParaRPr lang="en-US"/>
           </a:p>
@@ -2849,7 +2857,7 @@
           <a:p>
             <a:fld id="{BA94432C-A2F8-4335-967E-A9297080D7C3}" type="datetimeFigureOut">
               <a:rPr lang="en-US" smtClean="0"/>
-              <a:t>3/1/2026</a:t>
+              <a:t>3/2/2026</a:t>
             </a:fld>
             <a:endParaRPr lang="en-US"/>
           </a:p>
@@ -3160,7 +3168,7 @@
           <a:p>
             <a:fld id="{BA94432C-A2F8-4335-967E-A9297080D7C3}" type="datetimeFigureOut">
               <a:rPr lang="en-US" smtClean="0"/>
-              <a:t>3/1/2026</a:t>
+              <a:t>3/2/2026</a:t>
             </a:fld>
             <a:endParaRPr lang="en-US"/>
           </a:p>
@@ -3448,7 +3456,7 @@
           <a:p>
             <a:fld id="{BA94432C-A2F8-4335-967E-A9297080D7C3}" type="datetimeFigureOut">
               <a:rPr lang="en-US" smtClean="0"/>
-              <a:t>3/1/2026</a:t>
+              <a:t>3/2/2026</a:t>
             </a:fld>
             <a:endParaRPr lang="en-US"/>
           </a:p>
@@ -3689,7 +3697,7 @@
           <a:p>
             <a:fld id="{BA94432C-A2F8-4335-967E-A9297080D7C3}" type="datetimeFigureOut">
               <a:rPr lang="en-US" smtClean="0"/>
-              <a:t>3/1/2026</a:t>
+              <a:t>3/2/2026</a:t>
             </a:fld>
             <a:endParaRPr lang="en-US"/>
           </a:p>
@@ -4596,7 +4604,7 @@
             <a:pPr lvl="1"/>
             <a:r>
               <a:rPr lang="en-US" dirty="0"/>
-              <a:t>SF-36 Mental Component Summary (MCS) Score</a:t>
+              <a:t>SF-36 Mental Component Summary (MCS) Score </a:t>
             </a:r>
           </a:p>
           <a:p>
@@ -4610,7 +4618,7 @@
             <a:pPr lvl="1"/>
             <a:r>
               <a:rPr lang="en-US" dirty="0"/>
-              <a:t>HIV viral load (analyzed on log10 scale)</a:t>
+              <a:t>(log10) HIV viral load</a:t>
             </a:r>
           </a:p>
           <a:p>
@@ -4763,181 +4771,77 @@
           </a:p>
         </p:txBody>
       </p:sp>
-      <mc:AlternateContent xmlns:mc="http://schemas.openxmlformats.org/markup-compatibility/2006">
-        <mc:Choice xmlns:a14="http://schemas.microsoft.com/office/drawing/2010/main" Requires="a14">
-          <p:sp>
-            <p:nvSpPr>
-              <p:cNvPr id="3" name="Content Placeholder 2">
-                <a:extLst>
-                  <a:ext uri="{FF2B5EF4-FFF2-40B4-BE49-F238E27FC236}">
-                    <a16:creationId xmlns:a16="http://schemas.microsoft.com/office/drawing/2014/main" id="{A4CEC750-A8D1-9F91-D7A6-9E0E88E3D906}"/>
-                  </a:ext>
-                </a:extLst>
-              </p:cNvPr>
-              <p:cNvSpPr>
-                <a:spLocks noGrp="1"/>
-              </p:cNvSpPr>
-              <p:nvPr>
-                <p:ph idx="1"/>
-              </p:nvPr>
-            </p:nvSpPr>
-            <p:spPr>
-              <a:xfrm>
-                <a:off x="1189182" y="1825625"/>
-                <a:ext cx="4260274" cy="4351338"/>
-              </a:xfrm>
-            </p:spPr>
-            <p:txBody>
-              <a:bodyPr>
-                <a:normAutofit fontScale="92500" lnSpcReduction="20000"/>
-              </a:bodyPr>
-              <a:lstStyle/>
-              <a:p>
-                <a:r>
-                  <a:rPr lang="en-US" dirty="0"/>
-                  <a:t>715 total subjects</a:t>
-                </a:r>
-              </a:p>
-              <a:p>
-                <a:r>
-                  <a:rPr lang="en-US" dirty="0"/>
-                  <a:t>467 subjects with all outcomes measured at Baseline and Year 2</a:t>
-                </a:r>
-              </a:p>
-              <a:p>
-                <a:pPr lvl="1"/>
-                <a:r>
-                  <a:rPr lang="en-US" dirty="0"/>
-                  <a:t>41% missing for drug users</a:t>
-                </a:r>
-              </a:p>
-              <a:p>
-                <a:pPr lvl="1"/>
-                <a:r>
-                  <a:rPr lang="en-US" dirty="0"/>
-                  <a:t>32% missing for non-users</a:t>
-                </a:r>
-              </a:p>
-              <a:p>
-                <a:r>
-                  <a:rPr lang="en-US" dirty="0"/>
-                  <a:t>Covariates</a:t>
-                </a:r>
-              </a:p>
-              <a:p>
-                <a:pPr lvl="1"/>
-                <a:r>
-                  <a:rPr lang="en-US" dirty="0"/>
-                  <a:t>Age</a:t>
-                </a:r>
-              </a:p>
-              <a:p>
-                <a:pPr lvl="1"/>
-                <a:r>
-                  <a:rPr lang="en-US" dirty="0"/>
-                  <a:t>BMI</a:t>
-                </a:r>
-              </a:p>
-              <a:p>
-                <a:pPr lvl="2"/>
-                <a14:m>
-                  <m:oMath xmlns:m="http://schemas.openxmlformats.org/officeDocument/2006/math">
-                    <m:r>
-                      <a:rPr lang="en-US" b="0" i="1" smtClean="0">
-                        <a:latin typeface="Cambria Math" panose="02040503050406030204" pitchFamily="18" charset="0"/>
-                      </a:rPr>
-                      <m:t>0&lt;</m:t>
-                    </m:r>
-                    <m:r>
-                      <m:rPr>
-                        <m:sty m:val="p"/>
-                      </m:rPr>
-                      <a:rPr lang="en-US" b="0" i="1" smtClean="0">
-                        <a:latin typeface="Cambria Math" panose="02040503050406030204" pitchFamily="18" charset="0"/>
-                      </a:rPr>
-                      <m:t>BMI</m:t>
-                    </m:r>
-                    <m:r>
-                      <a:rPr lang="en-US" b="0" i="1" smtClean="0">
-                        <a:latin typeface="Cambria Math" panose="02040503050406030204" pitchFamily="18" charset="0"/>
-                      </a:rPr>
-                      <m:t>&lt;400</m:t>
-                    </m:r>
-                  </m:oMath>
-                </a14:m>
-                <a:endParaRPr lang="en-US" dirty="0"/>
-              </a:p>
-              <a:p>
-                <a:pPr lvl="1"/>
-                <a:r>
-                  <a:rPr lang="en-US" dirty="0"/>
-                  <a:t>Smoking Status</a:t>
-                </a:r>
-              </a:p>
-              <a:p>
-                <a:pPr lvl="1"/>
-                <a:r>
-                  <a:rPr lang="en-US" dirty="0"/>
-                  <a:t>Education</a:t>
-                </a:r>
-              </a:p>
-              <a:p>
-                <a:pPr lvl="1"/>
-                <a:r>
-                  <a:rPr lang="en-US" dirty="0"/>
-                  <a:t>Race/Ethnicity</a:t>
-                </a:r>
-              </a:p>
-              <a:p>
-                <a:endParaRPr lang="en-US" dirty="0"/>
-              </a:p>
-            </p:txBody>
-          </p:sp>
-        </mc:Choice>
-        <mc:Fallback>
-          <p:sp>
-            <p:nvSpPr>
-              <p:cNvPr id="3" name="Content Placeholder 2">
-                <a:extLst>
-                  <a:ext uri="{FF2B5EF4-FFF2-40B4-BE49-F238E27FC236}">
-                    <a16:creationId xmlns:a16="http://schemas.microsoft.com/office/drawing/2014/main" id="{A4CEC750-A8D1-9F91-D7A6-9E0E88E3D906}"/>
-                  </a:ext>
-                </a:extLst>
-              </p:cNvPr>
-              <p:cNvSpPr>
-                <a:spLocks noGrp="1" noRot="1" noChangeAspect="1" noMove="1" noResize="1" noEditPoints="1" noAdjustHandles="1" noChangeArrowheads="1" noChangeShapeType="1" noTextEdit="1"/>
-              </p:cNvSpPr>
-              <p:nvPr>
-                <p:ph idx="1"/>
-              </p:nvPr>
-            </p:nvSpPr>
-            <p:spPr>
-              <a:xfrm>
-                <a:off x="1189182" y="1825625"/>
-                <a:ext cx="4260274" cy="4351338"/>
-              </a:xfrm>
-              <a:blipFill>
-                <a:blip r:embed="rId2"/>
-                <a:stretch>
-                  <a:fillRect l="-2146" t="-3501"/>
-                </a:stretch>
-              </a:blipFill>
-            </p:spPr>
-            <p:txBody>
-              <a:bodyPr/>
-              <a:lstStyle/>
-              <a:p>
-                <a:r>
-                  <a:rPr lang="en-US">
-                    <a:noFill/>
-                  </a:rPr>
-                  <a:t> </a:t>
-                </a:r>
-              </a:p>
-            </p:txBody>
-          </p:sp>
-        </mc:Fallback>
-      </mc:AlternateContent>
+      <p:sp>
+        <p:nvSpPr>
+          <p:cNvPr id="3" name="Content Placeholder 2">
+            <a:extLst>
+              <a:ext uri="{FF2B5EF4-FFF2-40B4-BE49-F238E27FC236}">
+                <a16:creationId xmlns:a16="http://schemas.microsoft.com/office/drawing/2014/main" id="{A4CEC750-A8D1-9F91-D7A6-9E0E88E3D906}"/>
+              </a:ext>
+            </a:extLst>
+          </p:cNvPr>
+          <p:cNvSpPr>
+            <a:spLocks noGrp="1"/>
+          </p:cNvSpPr>
+          <p:nvPr>
+            <p:ph idx="1"/>
+          </p:nvPr>
+        </p:nvSpPr>
+        <p:spPr>
+          <a:xfrm>
+            <a:off x="1189182" y="1825625"/>
+            <a:ext cx="4260274" cy="4351338"/>
+          </a:xfrm>
+        </p:spPr>
+        <p:txBody>
+          <a:bodyPr>
+            <a:normAutofit lnSpcReduction="10000"/>
+          </a:bodyPr>
+          <a:lstStyle/>
+          <a:p>
+            <a:r>
+              <a:rPr lang="en-US" dirty="0"/>
+              <a:t>715 total subjects</a:t>
+            </a:r>
+          </a:p>
+          <a:p>
+            <a:r>
+              <a:rPr lang="en-US" dirty="0"/>
+              <a:t>467 subjects with all outcomes measured at Baseline and Year 2</a:t>
+            </a:r>
+          </a:p>
+          <a:p>
+            <a:pPr lvl="1"/>
+            <a:r>
+              <a:rPr lang="en-US" dirty="0"/>
+              <a:t>41% missing for drug users</a:t>
+            </a:r>
+          </a:p>
+          <a:p>
+            <a:pPr lvl="1"/>
+            <a:r>
+              <a:rPr lang="en-US" dirty="0"/>
+              <a:t>32% missing for non-users</a:t>
+            </a:r>
+          </a:p>
+          <a:p>
+            <a:r>
+              <a:rPr lang="en-US" dirty="0"/>
+              <a:t>Adherence</a:t>
+            </a:r>
+          </a:p>
+          <a:p>
+            <a:pPr lvl="1"/>
+            <a:r>
+              <a:rPr lang="en-US" dirty="0"/>
+              <a:t>Higher among hard drug users (n=1 with &lt;95%)</a:t>
+            </a:r>
+          </a:p>
+          <a:p>
+            <a:endParaRPr lang="en-US" dirty="0"/>
+          </a:p>
+        </p:txBody>
+      </p:sp>
       <p:pic>
         <p:nvPicPr>
           <p:cNvPr id="6" name="Picture 5">
@@ -4953,7 +4857,7 @@
           <p:nvPr/>
         </p:nvPicPr>
         <p:blipFill>
-          <a:blip r:embed="rId3"/>
+          <a:blip r:embed="rId2"/>
           <a:stretch>
             <a:fillRect/>
           </a:stretch>
@@ -4968,6 +4872,58 @@
           </a:prstGeom>
         </p:spPr>
       </p:pic>
+      <p:sp>
+        <p:nvSpPr>
+          <p:cNvPr id="5" name="Rectangle 4">
+            <a:extLst>
+              <a:ext uri="{FF2B5EF4-FFF2-40B4-BE49-F238E27FC236}">
+                <a16:creationId xmlns:a16="http://schemas.microsoft.com/office/drawing/2014/main" id="{6B6D4E1D-36AD-DBA0-97B4-432C7C311BD7}"/>
+              </a:ext>
+            </a:extLst>
+          </p:cNvPr>
+          <p:cNvSpPr/>
+          <p:nvPr/>
+        </p:nvSpPr>
+        <p:spPr>
+          <a:xfrm>
+            <a:off x="5713156" y="3886200"/>
+            <a:ext cx="5991626" cy="594360"/>
+          </a:xfrm>
+          <a:prstGeom prst="rect">
+            <a:avLst/>
+          </a:prstGeom>
+          <a:noFill/>
+          <a:ln>
+            <a:solidFill>
+              <a:srgbClr val="FF0000"/>
+            </a:solidFill>
+          </a:ln>
+        </p:spPr>
+        <p:style>
+          <a:lnRef idx="2">
+            <a:schemeClr val="accent1">
+              <a:shade val="15000"/>
+            </a:schemeClr>
+          </a:lnRef>
+          <a:fillRef idx="1">
+            <a:schemeClr val="accent1"/>
+          </a:fillRef>
+          <a:effectRef idx="0">
+            <a:schemeClr val="accent1"/>
+          </a:effectRef>
+          <a:fontRef idx="minor">
+            <a:schemeClr val="lt1"/>
+          </a:fontRef>
+        </p:style>
+        <p:txBody>
+          <a:bodyPr rtlCol="0" anchor="ctr"/>
+          <a:lstStyle/>
+          <a:p>
+            <a:pPr algn="ctr"/>
+            <a:endParaRPr lang="en-US"/>
+          </a:p>
+        </p:txBody>
+      </p:sp>
     </p:spTree>
     <p:extLst>
       <p:ext uri="{BB962C8B-B14F-4D97-AF65-F5344CB8AC3E}">
@@ -5110,7 +5066,7 @@
         </p:nvSpPr>
         <p:spPr>
           <a:xfrm>
-            <a:off x="6437745" y="1825625"/>
+            <a:off x="6446981" y="1825625"/>
             <a:ext cx="5248564" cy="4351338"/>
           </a:xfrm>
           <a:prstGeom prst="rect">
@@ -5288,39 +5244,17 @@
           <a:p>
             <a:r>
               <a:rPr lang="en-US" dirty="0"/>
-              <a:t>Frequentist Approach</a:t>
+              <a:t>Model Summaries</a:t>
             </a:r>
           </a:p>
           <a:p>
             <a:pPr lvl="1"/>
             <a:r>
-              <a:rPr lang="en-US" dirty="0"/>
-              <a:t>Multiple Linear Regression (OLS)</a:t>
-            </a:r>
-          </a:p>
-          <a:p>
-            <a:pPr lvl="2"/>
-            <a:r>
-              <a:rPr lang="en-US" dirty="0"/>
-              <a:t>Outcome: Year 2 – Baseline</a:t>
-            </a:r>
-          </a:p>
-          <a:p>
-            <a:pPr lvl="2"/>
-            <a:r>
-              <a:rPr lang="en-US" dirty="0"/>
-              <a:t>Adjusted for baseline measurement and covariates</a:t>
-            </a:r>
-          </a:p>
-          <a:p>
-            <a:pPr lvl="1"/>
-            <a:r>
-              <a:rPr lang="en-US" dirty="0"/>
-              <a:t>Model Summaries</a:t>
-            </a:r>
-            <a:endParaRPr lang="en-US" dirty="0">
-              <a:latin typeface="Aptos (Body)"/>
-            </a:endParaRPr>
+              <a:rPr lang="en-US" dirty="0">
+                <a:latin typeface="Aptos (Body)"/>
+              </a:rPr>
+              <a:t>Frequentist</a:t>
+            </a:r>
           </a:p>
           <a:p>
             <a:pPr lvl="2"/>
@@ -5337,7 +5271,7 @@
               <a:rPr lang="en-US" dirty="0">
                 <a:latin typeface="Aptos (Body)"/>
               </a:rPr>
-              <a:t>95% Confidence Intervals</a:t>
+              <a:t>95% Confidence Intervals (CI)</a:t>
             </a:r>
           </a:p>
           <a:p>
@@ -5346,15 +5280,53 @@
               <a:rPr lang="en-US" dirty="0">
                 <a:latin typeface="Aptos (Body)"/>
               </a:rPr>
-              <a:t>P-vales</a:t>
+              <a:t>p-values</a:t>
+            </a:r>
+          </a:p>
+          <a:p>
+            <a:pPr lvl="1"/>
+            <a:r>
+              <a:rPr lang="en-US" dirty="0">
+                <a:latin typeface="Aptos (Body)"/>
+              </a:rPr>
+              <a:t>Bayesian</a:t>
             </a:r>
           </a:p>
           <a:p>
             <a:pPr lvl="2"/>
-            <a:endParaRPr lang="en-US" dirty="0"/>
-          </a:p>
-          <a:p>
-            <a:pPr lvl="1"/>
+            <a:r>
+              <a:rPr lang="en-US" dirty="0">
+                <a:latin typeface="Aptos (Body)"/>
+              </a:rPr>
+              <a:t>Point Estimates</a:t>
+            </a:r>
+          </a:p>
+          <a:p>
+            <a:pPr lvl="2"/>
+            <a:r>
+              <a:rPr lang="en-US" dirty="0">
+                <a:latin typeface="Aptos (Body)"/>
+              </a:rPr>
+              <a:t>95% Highest Density Intervals (HDI)</a:t>
+            </a:r>
+          </a:p>
+          <a:p>
+            <a:pPr lvl="2"/>
+            <a:r>
+              <a:rPr lang="en-US" dirty="0">
+                <a:latin typeface="Aptos (Body)"/>
+              </a:rPr>
+              <a:t>Posterior Probabilities (PP)</a:t>
+            </a:r>
+          </a:p>
+          <a:p>
+            <a:pPr lvl="2"/>
+            <a:r>
+              <a:rPr lang="en-US" dirty="0">
+                <a:latin typeface="Aptos (Body)"/>
+              </a:rPr>
+              <a:t>LOO-IC</a:t>
+            </a:r>
             <a:endParaRPr lang="en-US" dirty="0"/>
           </a:p>
           <a:p>
@@ -5390,7 +5362,7 @@
             </p:spPr>
             <p:txBody>
               <a:bodyPr vert="horz" lIns="91440" tIns="45720" rIns="91440" bIns="45720" rtlCol="0">
-                <a:normAutofit/>
+                <a:normAutofit lnSpcReduction="10000"/>
               </a:bodyPr>
               <a:lstStyle>
                 <a:lvl1pPr marL="228600" indent="-228600" algn="l" defTabSz="914400" rtl="0" eaLnBrk="1" latinLnBrk="0" hangingPunct="1">
@@ -5559,14 +5531,21 @@
               <a:p>
                 <a:r>
                   <a:rPr lang="en-US" dirty="0"/>
-                  <a:t>Bayesian Approach</a:t>
+                  <a:t>Model Approach</a:t>
                 </a:r>
               </a:p>
               <a:p>
                 <a:pPr lvl="1"/>
                 <a:r>
                   <a:rPr lang="en-US" dirty="0"/>
-                  <a:t>Bayesian Multiple Linear Regression</a:t>
+                  <a:t>Multiple Linear Regression</a:t>
+                </a:r>
+              </a:p>
+              <a:p>
+                <a:pPr lvl="2"/>
+                <a:r>
+                  <a:rPr lang="en-US" dirty="0"/>
+                  <a:t>Bayesian and frequentist (OLS)</a:t>
                 </a:r>
               </a:p>
               <a:p>
@@ -5584,107 +5563,109 @@
                 </a:r>
               </a:p>
               <a:p>
+                <a:pPr lvl="3"/>
+                <a:r>
+                  <a:rPr lang="en-US" dirty="0"/>
+                  <a:t>Age, BMI, Smoking, Education, Race/Ethnicity</a:t>
+                </a:r>
+              </a:p>
+              <a:p>
+                <a:pPr lvl="1"/>
+                <a:r>
+                  <a:rPr lang="en-US" dirty="0"/>
+                  <a:t>Clinically Significant Thresholds</a:t>
+                </a:r>
+              </a:p>
+              <a:p>
                 <a:pPr lvl="2"/>
                 <a:r>
                   <a:rPr lang="en-US" dirty="0"/>
-                  <a:t>Non-informative Priors: </a:t>
+                  <a:t>MCS – 2 units</a:t>
+                </a:r>
+              </a:p>
+              <a:p>
+                <a:pPr lvl="2"/>
+                <a:r>
+                  <a:rPr lang="en-US" dirty="0"/>
+                  <a:t>PCS – 2 units</a:t>
+                </a:r>
+              </a:p>
+              <a:p>
+                <a:pPr lvl="2"/>
+                <a:r>
+                  <a:rPr lang="en-US" dirty="0"/>
+                  <a:t>log10 HIV viral load – 0.5 units</a:t>
+                </a:r>
+              </a:p>
+              <a:p>
+                <a:pPr lvl="2"/>
+                <a:r>
+                  <a:rPr lang="en-US" dirty="0"/>
+                  <a:t>CD4+ T cell count – </a:t>
                 </a:r>
                 <a14:m>
                   <m:oMath xmlns:m="http://schemas.openxmlformats.org/officeDocument/2006/math">
                     <m:r>
-                      <a:rPr lang="en-US" i="1" smtClean="0">
+                      <a:rPr lang="en-US" i="1" dirty="0" smtClean="0">
                         <a:latin typeface="Cambria Math" panose="02040503050406030204" pitchFamily="18" charset="0"/>
                       </a:rPr>
-                      <m:t>𝑁</m:t>
+                      <m:t>50</m:t>
                     </m:r>
                     <m:r>
-                      <a:rPr lang="en-US" i="1" smtClean="0">
+                      <a:rPr lang="en-US" b="0" i="1" dirty="0" smtClean="0">
                         <a:latin typeface="Cambria Math" panose="02040503050406030204" pitchFamily="18" charset="0"/>
                       </a:rPr>
-                      <m:t>(0,</m:t>
+                      <m:t> </m:t>
+                    </m:r>
+                    <m:r>
+                      <a:rPr lang="en-US" i="1" dirty="0" smtClean="0">
+                        <a:latin typeface="Cambria Math" panose="02040503050406030204" pitchFamily="18" charset="0"/>
+                      </a:rPr>
+                      <m:t>𝑐𝑒𝑙𝑙𝑠</m:t>
+                    </m:r>
+                    <m:r>
+                      <m:rPr>
+                        <m:lit/>
+                      </m:rPr>
+                      <a:rPr lang="en-US" i="1" dirty="0" smtClean="0">
+                        <a:latin typeface="Cambria Math" panose="02040503050406030204" pitchFamily="18" charset="0"/>
+                      </a:rPr>
+                      <m:t>/</m:t>
+                    </m:r>
+                    <m:r>
+                      <a:rPr lang="en-US" i="1" dirty="0" smtClean="0">
+                        <a:latin typeface="Cambria Math" panose="02040503050406030204" pitchFamily="18" charset="0"/>
+                      </a:rPr>
+                      <m:t>𝑚</m:t>
                     </m:r>
                     <m:sSup>
                       <m:sSupPr>
                         <m:ctrlPr>
-                          <a:rPr lang="en-US" i="1" smtClean="0">
+                          <a:rPr lang="en-US" i="1" dirty="0" smtClean="0">
                             <a:latin typeface="Cambria Math" panose="02040503050406030204" pitchFamily="18" charset="0"/>
                           </a:rPr>
                         </m:ctrlPr>
                       </m:sSupPr>
                       <m:e>
                         <m:r>
-                          <a:rPr lang="en-US" i="1" smtClean="0">
+                          <a:rPr lang="en-US" i="1" dirty="0" smtClean="0">
                             <a:latin typeface="Cambria Math" panose="02040503050406030204" pitchFamily="18" charset="0"/>
                           </a:rPr>
-                          <m:t>100</m:t>
+                          <m:t>𝑚</m:t>
                         </m:r>
                       </m:e>
                       <m:sup>
                         <m:r>
-                          <a:rPr lang="en-US" i="1" smtClean="0">
+                          <a:rPr lang="en-US" i="1" dirty="0" smtClean="0">
                             <a:latin typeface="Cambria Math" panose="02040503050406030204" pitchFamily="18" charset="0"/>
                           </a:rPr>
-                          <m:t>2</m:t>
+                          <m:t>3</m:t>
                         </m:r>
                       </m:sup>
                     </m:sSup>
-                    <m:r>
-                      <a:rPr lang="en-US" i="1" smtClean="0">
-                        <a:latin typeface="Cambria Math" panose="02040503050406030204" pitchFamily="18" charset="0"/>
-                      </a:rPr>
-                      <m:t>)</m:t>
-                    </m:r>
                   </m:oMath>
                 </a14:m>
-                <a:endParaRPr lang="en-US" i="1" dirty="0">
-                  <a:latin typeface="Cambria Math" panose="02040503050406030204" pitchFamily="18" charset="0"/>
-                </a:endParaRPr>
-              </a:p>
-              <a:p>
-                <a:pPr lvl="1"/>
-                <a:r>
-                  <a:rPr lang="en-US" dirty="0"/>
-                  <a:t>Model Summaries</a:t>
-                </a:r>
-                <a:endParaRPr lang="en-US" dirty="0">
-                  <a:latin typeface="Aptos (Body)"/>
-                </a:endParaRPr>
-              </a:p>
-              <a:p>
-                <a:pPr lvl="2"/>
-                <a:r>
-                  <a:rPr lang="en-US" dirty="0">
-                    <a:latin typeface="Aptos (Body)"/>
-                  </a:rPr>
-                  <a:t>Point Estimates</a:t>
-                </a:r>
-              </a:p>
-              <a:p>
-                <a:pPr lvl="2"/>
-                <a:r>
-                  <a:rPr lang="en-US" dirty="0">
-                    <a:latin typeface="Aptos (Body)"/>
-                  </a:rPr>
-                  <a:t>95% Highest Density Intervals</a:t>
-                </a:r>
-              </a:p>
-              <a:p>
-                <a:pPr lvl="2"/>
-                <a:r>
-                  <a:rPr lang="en-US" dirty="0">
-                    <a:latin typeface="Aptos (Body)"/>
-                  </a:rPr>
-                  <a:t>Posterior Probabilities</a:t>
-                </a:r>
-              </a:p>
-              <a:p>
-                <a:pPr lvl="2"/>
-                <a:r>
-                  <a:rPr lang="en-US" dirty="0">
-                    <a:latin typeface="Aptos (Body)"/>
-                  </a:rPr>
-                  <a:t>LOO-IC</a:t>
-                </a:r>
+                <a:endParaRPr lang="en-US" dirty="0"/>
               </a:p>
               <a:p>
                 <a:pPr lvl="2"/>
@@ -5727,7 +5708,7 @@
               <a:blipFill>
                 <a:blip r:embed="rId3"/>
                 <a:stretch>
-                  <a:fillRect l="-2091" t="-2381" r="-1742"/>
+                  <a:fillRect l="-2091" t="-3081" r="-1742"/>
                 </a:stretch>
               </a:blipFill>
             </p:spPr>
@@ -5894,7 +5875,7 @@
         </p:blipFill>
         <p:spPr>
           <a:xfrm>
-            <a:off x="6655772" y="2505316"/>
+            <a:off x="6734084" y="2222681"/>
             <a:ext cx="5229455" cy="3858250"/>
           </a:xfrm>
           <a:prstGeom prst="rect">
@@ -5924,8 +5905,8 @@
         </p:blipFill>
         <p:spPr>
           <a:xfrm>
-            <a:off x="5801360" y="365125"/>
-            <a:ext cx="6079883" cy="1710987"/>
+            <a:off x="5362832" y="172412"/>
+            <a:ext cx="6600707" cy="1857556"/>
           </a:xfrm>
           <a:prstGeom prst="rect">
             <a:avLst/>
@@ -6009,7 +5990,7 @@
             <a:pPr lvl="1"/>
             <a:r>
               <a:rPr lang="en-US" dirty="0"/>
-              <a:t>No significant differences in treatment response between hard drug users and non-hard drug users</a:t>
+              <a:t>No differences in treatment response between hard drug users and non-hard drug users</a:t>
             </a:r>
           </a:p>
         </p:txBody>
@@ -6140,8 +6121,8 @@
           </a:p>
         </p:txBody>
       </p:sp>
-      <mc:AlternateContent xmlns:mc="http://schemas.openxmlformats.org/markup-compatibility/2006">
-        <mc:Choice xmlns:a14="http://schemas.microsoft.com/office/drawing/2010/main" Requires="a14">
+      <mc:AlternateContent xmlns:mc="http://schemas.openxmlformats.org/markup-compatibility/2006" xmlns:a14="http://schemas.microsoft.com/office/drawing/2010/main">
+        <mc:Choice Requires="a14">
           <p:sp>
             <p:nvSpPr>
               <p:cNvPr id="3" name="Content Placeholder 2">
@@ -6304,7 +6285,7 @@
             </p:txBody>
           </p:sp>
         </mc:Choice>
-        <mc:Fallback>
+        <mc:Fallback xmlns="">
           <p:sp>
             <p:nvSpPr>
               <p:cNvPr id="3" name="Content Placeholder 2">
@@ -6572,7 +6553,7 @@
               <a:p>
                 <a:r>
                   <a:rPr lang="en-US" dirty="0"/>
-                  <a:t>HAART less effective at improving physical quality of life for hard drug users</a:t>
+                  <a:t>Less improvement in physical quality of life after HAART for hard drug users</a:t>
                 </a:r>
               </a:p>
               <a:p>
@@ -6649,7 +6630,7 @@
                 </a14:m>
                 <a:r>
                   <a:rPr lang="en-US" dirty="0"/>
-                  <a:t> prior my be too informative for CD4+Counts</a:t>
+                  <a:t> prior may be too informative for CD4+ Counts</a:t>
                 </a:r>
               </a:p>
               <a:p>

</xml_diff>